<commit_message>
pm-method 2.3.0: entrega final del webinar, regla del presupuesto de cambio y documentos HTML
- Regla PRINCE2 al registrar cambios: la autoridad delegada no puede aprobar sin saldo ni sobre su límite; la junta aprueba indicando la fuente

- Mapas de Wardley y recorrido del cliente en el tablero del proyecto y en E2E-4 y E2E-5

- Webinar: guía, guion y ejercicio autocontenido con ejemplo resuelto, en HTML, con índice

- Spot de 54 s, resumen ejecutivo e Informe 2 con cifras finales; Docker reconstruido y probado

- Pruebas: 223 OK (3.13) y 222 (3.9); integración cruzada 61 OK
</commit_message>
<xml_diff>
--- a/docs/resumen-ejecutivo/resumen-ejecutivo-pm-method.pptx
+++ b/docs/resumen-ejecutivo/resumen-ejecutivo-pm-method.pptx
@@ -124,14 +124,14 @@
   <p:extLst>
     <p:ext uri="{521415D9-36F7-43E2-AB2F-B90AF26B5E84}">
       <p14:sectionLst xmlns:p14="http://schemas.microsoft.com/office/powerpoint/2010/main">
-        <p14:section name="Propuesta" id="{dfc8cfe3-975b-7d66-a66e-d16027930e8d}">
+        <p14:section name="Propuesta" id="{ab487459-ad57-071d-4017-92c8a8d57cc7}">
           <p14:sldIdLst>
             <p14:sldId id="256"/>
             <p14:sldId id="257"/>
             <p14:sldId id="258"/>
           </p14:sldIdLst>
         </p14:section>
-        <p14:section name="Producto" id="{180a3aed-c3a6-da03-cdd3-3a8f766c78f8}">
+        <p14:section name="Producto" id="{c4de38c1-f90d-112d-9c46-911a8b944633}">
           <p14:sldIdLst>
             <p14:sldId id="259"/>
             <p14:sldId id="260"/>
@@ -141,7 +141,7 @@
             <p14:sldId id="264"/>
           </p14:sldIdLst>
         </p14:section>
-        <p14:section name="Casos E2E" id="{0bb15fcc-3869-5602-9342-c8676ce89ba8}">
+        <p14:section name="Casos E2E" id="{3999a9e4-8904-4c7f-3973-f30a1eb7ce6f}">
           <p14:sldIdLst>
             <p14:sldId id="265"/>
             <p14:sldId id="266"/>
@@ -151,7 +151,7 @@
             <p14:sldId id="270"/>
           </p14:sldIdLst>
         </p14:section>
-        <p14:section name="Confianza y adopción" id="{0f59116f-4bed-2148-0e4c-6cbe74f9cf36}">
+        <p14:section name="Confianza y adopción" id="{c543d76e-abc9-1711-0595-4938d9a7f839}">
           <p14:sldIdLst>
             <p14:sldId id="271"/>
             <p14:sldId id="272"/>
@@ -6853,7 +6853,7 @@
                   <a:srgbClr val="272425"/>
                 </a:solidFill>
               </a:rPr>
-              <a:t>guía paso a paso por prompts, guion del instructor minuto a minuto, ejercicio con solución de referencia y diapositivas PPTX y HTML que regenera un script.</a:t>
+              <a:t>guía paso a paso por prompts, guion del instructor minuto a minuto, ejercicio autocontenido con ejemplo resuelto y diapositivas PPTX y HTML que regenera un script.</a:t>
             </a:r>
             <a:endParaRPr lang="en-US" sz="1200" dirty="0"/>
           </a:p>
@@ -10283,7 +10283,7 @@
                   <a:srgbClr val="FFFFFF"/>
                 </a:solidFill>
               </a:rPr>
-              <a:t>216</a:t>
+              <a:t>223</a:t>
             </a:r>
             <a:endParaRPr lang="en-US" sz="2800" dirty="0"/>
           </a:p>
@@ -10355,7 +10355,7 @@
                   <a:srgbClr val="FFFFFF"/>
                 </a:solidFill>
               </a:rPr>
-              <a:t>0 FALLO · 20 casos</a:t>
+              <a:t>0 FALLO · 21 casos</a:t>
             </a:r>
             <a:endParaRPr lang="en-US" sz="1000" dirty="0"/>
           </a:p>

</xml_diff>

<commit_message>
pm-method 2.4.0: contingencias, personas, radar, lecciones, impacto, auditoría y material de formación
</commit_message>
<xml_diff>
--- a/docs/resumen-ejecutivo/resumen-ejecutivo-pm-method.pptx
+++ b/docs/resumen-ejecutivo/resumen-ejecutivo-pm-method.pptx
@@ -124,14 +124,14 @@
   <p:extLst>
     <p:ext uri="{521415D9-36F7-43E2-AB2F-B90AF26B5E84}">
       <p14:sectionLst xmlns:p14="http://schemas.microsoft.com/office/powerpoint/2010/main">
-        <p14:section name="Propuesta" id="{ab487459-ad57-071d-4017-92c8a8d57cc7}">
+        <p14:section name="Propuesta" id="{1f16855e-d707-d705-12c4-9864628e5e79}">
           <p14:sldIdLst>
             <p14:sldId id="256"/>
             <p14:sldId id="257"/>
             <p14:sldId id="258"/>
           </p14:sldIdLst>
         </p14:section>
-        <p14:section name="Producto" id="{c4de38c1-f90d-112d-9c46-911a8b944633}">
+        <p14:section name="Producto" id="{f6615d53-8209-4a79-688a-6dabd079187d}">
           <p14:sldIdLst>
             <p14:sldId id="259"/>
             <p14:sldId id="260"/>
@@ -141,7 +141,7 @@
             <p14:sldId id="264"/>
           </p14:sldIdLst>
         </p14:section>
-        <p14:section name="Casos E2E" id="{3999a9e4-8904-4c7f-3973-f30a1eb7ce6f}">
+        <p14:section name="Casos E2E" id="{64b86be7-ae62-12aa-5c74-f69851bd773d}">
           <p14:sldIdLst>
             <p14:sldId id="265"/>
             <p14:sldId id="266"/>
@@ -151,7 +151,7 @@
             <p14:sldId id="270"/>
           </p14:sldIdLst>
         </p14:section>
-        <p14:section name="Confianza y adopción" id="{c543d76e-abc9-1711-0595-4938d9a7f839}">
+        <p14:section name="Confianza y adopción" id="{44a01161-231b-8d98-1bc7-aac47af9050f}">
           <p14:sldIdLst>
             <p14:sldId id="271"/>
             <p14:sldId id="272"/>
@@ -259,13 +259,13 @@
                     <c:v>REG · registros</c:v>
                   </c:pt>
                   <c:pt idx="9">
-                    <c:v>STK · maestro de interesados</c:v>
+                    <c:v>EST · estado, roles y puertas</c:v>
                   </c:pt>
                   <c:pt idx="10">
-                    <c:v>EST · estado, roles y puertas</c:v>
+                    <c:v>ESP · especificación y BMAD</c:v>
                   </c:pt>
                   <c:pt idx="11">
-                    <c:v>ESP · especificación y BMAD</c:v>
+                    <c:v>STK · maestro de interesados</c:v>
                   </c:pt>
                 </c:lvl>
               </c:multiLvlStrCache>
@@ -284,7 +284,7 @@
                   <c:v>3</c:v>
                 </c:pt>
                 <c:pt idx="2">
-                  <c:v>3</c:v>
+                  <c:v>4</c:v>
                 </c:pt>
                 <c:pt idx="3">
                   <c:v>0</c:v>
@@ -397,13 +397,13 @@
                     <c:v>REG · registros</c:v>
                   </c:pt>
                   <c:pt idx="9">
-                    <c:v>STK · maestro de interesados</c:v>
+                    <c:v>EST · estado, roles y puertas</c:v>
                   </c:pt>
                   <c:pt idx="10">
-                    <c:v>EST · estado, roles y puertas</c:v>
+                    <c:v>ESP · especificación y BMAD</c:v>
                   </c:pt>
                   <c:pt idx="11">
-                    <c:v>ESP · especificación y BMAD</c:v>
+                    <c:v>STK · maestro de interesados</c:v>
                   </c:pt>
                 </c:lvl>
               </c:multiLvlStrCache>
@@ -440,16 +440,16 @@
                   <c:v>6</c:v>
                 </c:pt>
                 <c:pt idx="8">
-                  <c:v>9</c:v>
+                  <c:v>12</c:v>
                 </c:pt>
                 <c:pt idx="9">
-                  <c:v>13</c:v>
+                  <c:v>14</c:v>
                 </c:pt>
                 <c:pt idx="10">
-                  <c:v>14</c:v>
+                  <c:v>15</c:v>
                 </c:pt>
                 <c:pt idx="11">
-                  <c:v>15</c:v>
+                  <c:v>17</c:v>
                 </c:pt>
               </c:numCache>
             </c:numRef>
@@ -2824,7 +2824,7 @@
                   <a:srgbClr val="696969"/>
                 </a:solidFill>
               </a:rPr>
-              <a:t>pm-method 2.3.0 · Resumen ejecutivo · 2026-10-20</a:t>
+              <a:t>pm-method 2.4.0 · Resumen ejecutivo · 2026-10-22</a:t>
             </a:r>
             <a:endParaRPr lang="en-US" sz="900" dirty="0"/>
           </a:p>
@@ -3254,7 +3254,7 @@
                   <a:srgbClr val="9FD0F0"/>
                 </a:solidFill>
               </a:rPr>
-              <a:t>Resumen ejecutivo · pm-method 2.3.0</a:t>
+              <a:t>Resumen ejecutivo · pm-method 2.4.0</a:t>
             </a:r>
             <a:endParaRPr lang="en-US" sz="1500" dirty="0"/>
           </a:p>
@@ -3326,7 +3326,7 @@
                   <a:srgbClr val="FFFFFF"/>
                 </a:solidFill>
               </a:rPr>
-              <a:t>Un plugin para Claude Code y Cowork. PRINCE2 7 manda, PMBOK 8 aporta las técnicas y BMAD es la especificación del producto, de solo lectura.</a:t>
+              <a:t>Un plugin para Claude Code y Cowork. PRINCE2 7 manda, PMBOK 8 aporta las técnicas y BMAD es la especificación del producto, de solo lectura. Con la versión 2.4.0: opciones e impacto medidos antes de decidir, un radar de lo que hay que decidir hoy e informes verificados contra el dato.</a:t>
             </a:r>
             <a:endParaRPr lang="en-US" sz="1200" dirty="0"/>
           </a:p>
@@ -3686,7 +3686,7 @@
                   <a:srgbClr val="FFFFFF"/>
                 </a:solidFill>
               </a:rPr>
-              <a:t>97</a:t>
+              <a:t>105</a:t>
             </a:r>
             <a:endParaRPr lang="en-US" sz="3000" dirty="0"/>
           </a:p>
@@ -3857,7 +3857,7 @@
                   <a:srgbClr val="FFFFFF"/>
                 </a:solidFill>
               </a:rPr>
-              <a:t>pm-method 2.3.0 · 20 de octubre de 2026</a:t>
+              <a:t>pm-method 2.4.0 · 22 de octubre de 2026</a:t>
             </a:r>
             <a:endParaRPr lang="en-US" sz="1100" dirty="0"/>
           </a:p>
@@ -4554,7 +4554,7 @@
                           <a:ea typeface="Arial" pitchFamily="34" charset="-122"/>
                           <a:cs typeface="Arial" pitchFamily="34" charset="-120"/>
                         </a:rPr>
-                        <a:t>Riesgos desde cuatro fuentes, respuestas costeadas, reserva vigilada y escalamiento a la junta</a:t>
+                        <a:t>Riesgos desde cuatro fuentes, opciones por valor neto, plan de contingencia y reserva vigilada</a:t>
                       </a:r>
                       <a:endParaRPr lang="en-US" sz="1200" dirty="0">
                         <a:latin typeface="Arial" charset="0"/>
@@ -4814,7 +4814,7 @@
                           <a:ea typeface="Arial" pitchFamily="34" charset="-122"/>
                           <a:cs typeface="Arial" pitchFamily="34" charset="-120"/>
                         </a:rPr>
-                        <a:t>37</a:t>
+                        <a:t>39</a:t>
                       </a:r>
                       <a:endParaRPr lang="en-US" sz="1200" dirty="0">
                         <a:latin typeface="Arial" charset="0"/>
@@ -4879,7 +4879,7 @@
                           <a:ea typeface="Arial" pitchFamily="34" charset="-122"/>
                           <a:cs typeface="Arial" pitchFamily="34" charset="-120"/>
                         </a:rPr>
-                        <a:t>24</a:t>
+                        <a:t>25</a:t>
                       </a:r>
                       <a:endParaRPr lang="en-US" sz="1200" dirty="0">
                         <a:latin typeface="Arial" charset="0"/>
@@ -5011,7 +5011,7 @@
                           <a:ea typeface="Arial" pitchFamily="34" charset="-122"/>
                           <a:cs typeface="Arial" pitchFamily="34" charset="-120"/>
                         </a:rPr>
-                        <a:t>Alcance por productos, estimación, priorización, cambio con presupuesto y excepción</a:t>
+                        <a:t>Alcance, tres valores, capacidad del release, impacto de cada cambio y excepción</a:t>
                       </a:r>
                       <a:endParaRPr lang="en-US" sz="1200" dirty="0">
                         <a:latin typeface="Arial" charset="0"/>
@@ -5271,7 +5271,7 @@
                           <a:ea typeface="Arial" pitchFamily="34" charset="-122"/>
                           <a:cs typeface="Arial" pitchFamily="34" charset="-120"/>
                         </a:rPr>
-                        <a:t>35</a:t>
+                        <a:t>37</a:t>
                       </a:r>
                       <a:endParaRPr lang="en-US" sz="1200" dirty="0">
                         <a:latin typeface="Arial" charset="0"/>
@@ -5468,7 +5468,7 @@
                           <a:ea typeface="Arial" pitchFamily="34" charset="-122"/>
                           <a:cs typeface="Arial" pitchFamily="34" charset="-120"/>
                         </a:rPr>
-                        <a:t>Interesados, preferencias, RACI, OKR, highlight desde el dato y envío por canales</a:t>
+                        <a:t>Interesados, acuerdos de reunión, radar, highlight desde el dato y envío por canales</a:t>
                       </a:r>
                       <a:endParaRPr lang="en-US" sz="1200" dirty="0">
                         <a:latin typeface="Arial" charset="0"/>
@@ -5728,7 +5728,7 @@
                           <a:ea typeface="Arial" pitchFamily="34" charset="-122"/>
                           <a:cs typeface="Arial" pitchFamily="34" charset="-120"/>
                         </a:rPr>
-                        <a:t>38</a:t>
+                        <a:t>39</a:t>
                       </a:r>
                       <a:endParaRPr lang="en-US" sz="1200" dirty="0">
                         <a:latin typeface="Arial" charset="0"/>
@@ -5925,7 +5925,7 @@
                           <a:ea typeface="Arial" pitchFamily="34" charset="-122"/>
                           <a:cs typeface="Arial" pitchFamily="34" charset="-120"/>
                         </a:rPr>
-                        <a:t>Producto con BMAD: condiciones formales, calidad a volumen, cierre y beneficios</a:t>
+                        <a:t>Producto con BMAD: calidad a volumen, ciclo de las lecciones, cierre por id y auditoría</a:t>
                       </a:r>
                       <a:endParaRPr lang="en-US" sz="1200" dirty="0">
                         <a:latin typeface="Arial" charset="0"/>
@@ -5990,7 +5990,7 @@
                           <a:ea typeface="Arial" pitchFamily="34" charset="-122"/>
                           <a:cs typeface="Arial" pitchFamily="34" charset="-120"/>
                         </a:rPr>
-                        <a:t>12</a:t>
+                        <a:t>15</a:t>
                       </a:r>
                       <a:endParaRPr lang="en-US" sz="1200" dirty="0">
                         <a:latin typeface="Arial" charset="0"/>
@@ -6185,7 +6185,7 @@
                           <a:ea typeface="Arial" pitchFamily="34" charset="-122"/>
                           <a:cs typeface="Arial" pitchFamily="34" charset="-120"/>
                         </a:rPr>
-                        <a:t>36</a:t>
+                        <a:t>40</a:t>
                       </a:r>
                       <a:endParaRPr lang="en-US" sz="1200" dirty="0">
                         <a:latin typeface="Arial" charset="0"/>
@@ -6382,7 +6382,7 @@
                           <a:ea typeface="Arial" pitchFamily="34" charset="-122"/>
                           <a:cs typeface="Arial" pitchFamily="34" charset="-120"/>
                         </a:rPr>
-                        <a:t>De la idea al proyecto diseñado: supuestos, opciones con VAN, enfoque y mapas</a:t>
+                        <a:t>De la idea al proyecto: lecciones previas, supuestos, VAN, personas de usuario y mapas</a:t>
                       </a:r>
                       <a:endParaRPr lang="en-US" sz="1200" dirty="0">
                         <a:latin typeface="Arial" charset="0"/>
@@ -6447,7 +6447,7 @@
                           <a:ea typeface="Arial" pitchFamily="34" charset="-122"/>
                           <a:cs typeface="Arial" pitchFamily="34" charset="-120"/>
                         </a:rPr>
-                        <a:t>18</a:t>
+                        <a:t>20</a:t>
                       </a:r>
                       <a:endParaRPr lang="en-US" sz="1200" dirty="0">
                         <a:latin typeface="Arial" charset="0"/>
@@ -7202,7 +7202,7 @@
               <a:buNone/>
             </a:pPr>
             <a:r>
-              <a:rPr lang="en-US" sz="1250" b="1" dirty="0">
+              <a:rPr lang="en-US" sz="1150" b="1" dirty="0">
                 <a:solidFill>
                   <a:srgbClr val="00629B"/>
                 </a:solidFill>
@@ -7216,14 +7216,14 @@
               <a:buNone/>
             </a:pPr>
             <a:r>
-              <a:rPr lang="en-US" sz="1250" dirty="0">
+              <a:rPr lang="en-US" sz="1150" dirty="0">
                 <a:solidFill>
                   <a:srgbClr val="272425"/>
                 </a:solidFill>
               </a:rPr>
               <a:t>Riesgos candidatos desde BMAD, transcripciones, Jira y artefactos, con cita de origen</a:t>
             </a:r>
-            <a:endParaRPr lang="en-US" sz="1250" dirty="0"/>
+            <a:endParaRPr lang="en-US" sz="1150" dirty="0"/>
           </a:p>
           <a:p>
             <a:pPr indent="0" marL="0">
@@ -7233,7 +7233,7 @@
               <a:buNone/>
             </a:pPr>
             <a:r>
-              <a:rPr lang="en-US" sz="1250" b="1" dirty="0">
+              <a:rPr lang="en-US" sz="1150" b="1" dirty="0">
                 <a:solidFill>
                   <a:srgbClr val="00629B"/>
                 </a:solidFill>
@@ -7247,14 +7247,14 @@
               <a:buNone/>
             </a:pPr>
             <a:r>
-              <a:rPr lang="en-US" sz="1250" dirty="0">
+              <a:rPr lang="en-US" sz="1150" dirty="0">
                 <a:solidFill>
                   <a:srgbClr val="272425"/>
                 </a:solidFill>
               </a:rPr>
-              <a:t>Respuestas justificadas por su costo frente a la reducción del valor monetario esperado</a:t>
-            </a:r>
-            <a:endParaRPr lang="en-US" sz="1250" dirty="0"/>
+              <a:t>Opciones de respuesta comparadas por valor neto; decide el propietario y el plan de contingencia queda listo</a:t>
+            </a:r>
+            <a:endParaRPr lang="en-US" sz="1150" dirty="0"/>
           </a:p>
           <a:p>
             <a:pPr indent="0" marL="0">
@@ -7264,7 +7264,7 @@
               <a:buNone/>
             </a:pPr>
             <a:r>
-              <a:rPr lang="en-US" sz="1250" b="1" dirty="0">
+              <a:rPr lang="en-US" sz="1150" b="1" dirty="0">
                 <a:solidFill>
                   <a:srgbClr val="00629B"/>
                 </a:solidFill>
@@ -7278,14 +7278,14 @@
               <a:buNone/>
             </a:pPr>
             <a:r>
-              <a:rPr lang="en-US" sz="1250" dirty="0">
+              <a:rPr lang="en-US" sz="1150" dirty="0">
                 <a:solidFill>
                   <a:srgbClr val="272425"/>
                 </a:solidFill>
               </a:rPr>
-              <a:t>Reserva de riesgo vigilada como presupuesto vivo de la junta</a:t>
-            </a:r>
-            <a:endParaRPr lang="en-US" sz="1250" dirty="0"/>
+              <a:t>Presupuesto de riesgo vigilado y reserva de gestión de la junta para lo no identificado</a:t>
+            </a:r>
+            <a:endParaRPr lang="en-US" sz="1150" dirty="0"/>
           </a:p>
         </p:txBody>
       </p:sp>
@@ -7380,7 +7380,7 @@
               <a:buNone/>
             </a:pPr>
             <a:r>
-              <a:rPr lang="en-US" sz="1150" b="1" dirty="0">
+              <a:rPr lang="en-US" sz="1000" b="1" dirty="0">
                 <a:solidFill>
                   <a:srgbClr val="B5651D"/>
                 </a:solidFill>
@@ -7394,14 +7394,14 @@
               <a:buNone/>
             </a:pPr>
             <a:r>
-              <a:rPr lang="en-US" sz="1150" dirty="0">
+              <a:rPr lang="en-US" sz="1000" dirty="0">
                 <a:solidFill>
                   <a:srgbClr val="272425"/>
                 </a:solidFill>
               </a:rPr>
-              <a:t>Dos amenazas en zona alta al salir del taller; con las respuestas del paso 6, ninguna queda en zona alta.</a:t>
-            </a:r>
-            <a:endParaRPr lang="en-US" sz="1150" dirty="0"/>
+              <a:t>Para R-001 conviene reducir; para R-003, preparar la contingencia. En los dos, evitar deja el residual más bajo pero no el mayor valor neto: cuesta más y crea un riesgo secundario.</a:t>
+            </a:r>
+            <a:endParaRPr lang="en-US" sz="1000" dirty="0"/>
           </a:p>
           <a:p>
             <a:pPr indent="0" marL="0">
@@ -7411,7 +7411,7 @@
               <a:buNone/>
             </a:pPr>
             <a:r>
-              <a:rPr lang="en-US" sz="1150" b="1" dirty="0">
+              <a:rPr lang="en-US" sz="1000" b="1" dirty="0">
                 <a:solidFill>
                   <a:srgbClr val="B5651D"/>
                 </a:solidFill>
@@ -7425,14 +7425,14 @@
               <a:buNone/>
             </a:pPr>
             <a:r>
-              <a:rPr lang="en-US" sz="1150" dirty="0">
+              <a:rPr lang="en-US" sz="1000" dirty="0">
                 <a:solidFill>
                   <a:srgbClr val="272425"/>
                 </a:solidFill>
               </a:rPr>
-              <a:t>La reserva pasa del 21 % al 81 % en cinco corridas de la sanidad; al cruzar el 80 %, CAM-03 deja de ser informativo y avisa.</a:t>
-            </a:r>
-            <a:endParaRPr lang="en-US" sz="1150" dirty="0"/>
+              <a:t>La reserva pasa del 18 % al 94 % en cinco corridas de la sanidad; al activar el plan de contingencia de R-003 cruza el 80 % y CAM-03 deja de ser informativo y avisa. La provisión para lo no identificado no está en esas barras: vive en la reserva de gestión, que solo libera la junta.</a:t>
+            </a:r>
+            <a:endParaRPr lang="en-US" sz="1000" dirty="0"/>
           </a:p>
           <a:p>
             <a:pPr indent="0" marL="0">
@@ -7442,7 +7442,7 @@
               <a:buNone/>
             </a:pPr>
             <a:r>
-              <a:rPr lang="en-US" sz="1150" b="1" dirty="0">
+              <a:rPr lang="en-US" sz="1000" b="1" dirty="0">
                 <a:solidFill>
                   <a:srgbClr val="B5651D"/>
                 </a:solidFill>
@@ -7456,20 +7456,20 @@
               <a:buNone/>
             </a:pPr>
             <a:r>
-              <a:rPr lang="en-US" sz="1150" dirty="0">
+              <a:rPr lang="en-US" sz="1000" dirty="0">
                 <a:solidFill>
                   <a:srgbClr val="272425"/>
                 </a:solidFill>
               </a:rPr>
-              <a:t>El estado de riesgo en una sola vista para la junta del límite de etapa: lo único en atención es la reserva.</a:t>
-            </a:r>
-            <a:endParaRPr lang="en-US" sz="1150" dirty="0"/>
+              <a:t>El estado de riesgo en una sola vista para la junta del límite de etapa: lo único en atención es la reserva de riesgo; la reserva de gestión sigue intacta.</a:t>
+            </a:r>
+            <a:endParaRPr lang="en-US" sz="1000" dirty="0"/>
           </a:p>
         </p:txBody>
       </p:sp>
       <p:pic>
         <p:nvPicPr>
-          <p:cNvPr id="11" name="Image 0" descr="/home/claude/pm-method/docs/guias/img/g1-consumo-reserva.png">    </p:cNvPr>
+          <p:cNvPr id="11" name="Image 0" descr="/home/claude/pm-method/docs/guias/img/g1-opciones-valor-neto.png">    </p:cNvPr>
           <p:cNvPicPr>
             <a:picLocks noChangeAspect="1"/>
           </p:cNvPicPr>
@@ -7521,7 +7521,7 @@
                   <a:srgbClr val="696969"/>
                 </a:solidFill>
               </a:rPr>
-              <a:t>Consumo de la reserva de riesgo</a:t>
+              <a:t>Valor neto de las opciones de respuesta</a:t>
             </a:r>
             <a:endParaRPr lang="en-US" sz="1000" dirty="0"/>
           </a:p>
@@ -7834,7 +7834,7 @@
               <a:buNone/>
             </a:pPr>
             <a:r>
-              <a:rPr lang="en-US" sz="1250" b="1" dirty="0">
+              <a:rPr lang="en-US" sz="1150" b="1" dirty="0">
                 <a:solidFill>
                   <a:srgbClr val="00629B"/>
                 </a:solidFill>
@@ -7848,14 +7848,14 @@
               <a:buNone/>
             </a:pPr>
             <a:r>
-              <a:rPr lang="en-US" sz="1250" dirty="0">
+              <a:rPr lang="en-US" sz="1150" dirty="0">
                 <a:solidFill>
                   <a:srgbClr val="272425"/>
                 </a:solidFill>
               </a:rPr>
-              <a:t>Alcance por productos trazado a requisitos e historias</a:t>
-            </a:r>
-            <a:endParaRPr lang="en-US" sz="1250" dirty="0"/>
+              <a:t>Tres valores, reserva de cronograma y capacidad del release por MoSCoW</a:t>
+            </a:r>
+            <a:endParaRPr lang="en-US" sz="1150" dirty="0"/>
           </a:p>
           <a:p>
             <a:pPr indent="0" marL="0">
@@ -7865,7 +7865,7 @@
               <a:buNone/>
             </a:pPr>
             <a:r>
-              <a:rPr lang="en-US" sz="1250" b="1" dirty="0">
+              <a:rPr lang="en-US" sz="1150" b="1" dirty="0">
                 <a:solidFill>
                   <a:srgbClr val="00629B"/>
                 </a:solidFill>
@@ -7879,14 +7879,14 @@
               <a:buNone/>
             </a:pPr>
             <a:r>
-              <a:rPr lang="en-US" sz="1250" dirty="0">
+              <a:rPr lang="en-US" sz="1150" dirty="0">
                 <a:solidFill>
                   <a:srgbClr val="272425"/>
                 </a:solidFill>
               </a:rPr>
-              <a:t>Presupuesto y límite de la autoridad de cambio registrados por la junta</a:t>
-            </a:r>
-            <a:endParaRPr lang="en-US" sz="1250" dirty="0"/>
+              <a:t>Análisis de impacto antes de decidir: tiempo, capacidad, presupuesto, VAN y quién decide</a:t>
+            </a:r>
+            <a:endParaRPr lang="en-US" sz="1150" dirty="0"/>
           </a:p>
           <a:p>
             <a:pPr indent="0" marL="0">
@@ -7896,7 +7896,7 @@
               <a:buNone/>
             </a:pPr>
             <a:r>
-              <a:rPr lang="en-US" sz="1250" b="1" dirty="0">
+              <a:rPr lang="en-US" sz="1150" b="1" dirty="0">
                 <a:solidFill>
                   <a:srgbClr val="00629B"/>
                 </a:solidFill>
@@ -7910,14 +7910,14 @@
               <a:buNone/>
             </a:pPr>
             <a:r>
-              <a:rPr lang="en-US" sz="1250" dirty="0">
+              <a:rPr lang="en-US" sz="1150" dirty="0">
                 <a:solidFill>
                   <a:srgbClr val="272425"/>
                 </a:solidFill>
               </a:rPr>
               <a:t>Excepción completa: detectada, informada, replanificada y autorizada</a:t>
             </a:r>
-            <a:endParaRPr lang="en-US" sz="1250" dirty="0"/>
+            <a:endParaRPr lang="en-US" sz="1150" dirty="0"/>
           </a:p>
         </p:txBody>
       </p:sp>
@@ -8012,7 +8012,7 @@
               <a:buNone/>
             </a:pPr>
             <a:r>
-              <a:rPr lang="en-US" sz="1100" b="1" dirty="0">
+              <a:rPr lang="en-US" sz="1000" b="1" dirty="0">
                 <a:solidFill>
                   <a:srgbClr val="B5651D"/>
                 </a:solidFill>
@@ -8026,14 +8026,14 @@
               <a:buNone/>
             </a:pPr>
             <a:r>
-              <a:rPr lang="en-US" sz="1100" dirty="0">
+              <a:rPr lang="en-US" sz="1000" dirty="0">
                 <a:solidFill>
                   <a:srgbClr val="272425"/>
                 </a:solidFill>
               </a:rPr>
-              <a:t>El presupuesto de cambio queda en 75 % tras C-001; con C-002 llegaría al 200 %, por eso C-002 espera a la junta, que amplía el presupuesto y lo aprueba: vuelve a 75 % (paso 10).</a:t>
-            </a:r>
-            <a:endParaRPr lang="en-US" sz="1100" dirty="0"/>
+              <a:t>C-002 usaría el 200 % del presupuesto de cambio, el 150 % del límite de quien lo aprobó de palabra y el 143 % de la tolerancia de tiempo de la etapa: no lo puede decidir la autoridad de cambio, lo decide la junta (paso 10).</a:t>
+            </a:r>
+            <a:endParaRPr lang="en-US" sz="1000" dirty="0"/>
           </a:p>
           <a:p>
             <a:pPr indent="0" marL="0">
@@ -8043,7 +8043,7 @@
               <a:buNone/>
             </a:pPr>
             <a:r>
-              <a:rPr lang="en-US" sz="1100" b="1" dirty="0">
+              <a:rPr lang="en-US" sz="1000" b="1" dirty="0">
                 <a:solidFill>
                   <a:srgbClr val="B5651D"/>
                 </a:solidFill>
@@ -8057,14 +8057,14 @@
               <a:buNone/>
             </a:pPr>
             <a:r>
-              <a:rPr lang="en-US" sz="1100" dirty="0">
+              <a:rPr lang="en-US" sz="1000" dirty="0">
                 <a:solidFill>
                   <a:srgbClr val="272425"/>
                 </a:solidFill>
               </a:rPr>
               <a:t>El 29/1 no entra el 10,3 % del alcance (ámbar, lo gestiona el PO); el 19/2 no entra el 22,1 %, más que el 20 % de margen: los Must peligran y hay excepción (pasos 9 y 10).</a:t>
             </a:r>
-            <a:endParaRPr lang="en-US" sz="1100" dirty="0"/>
+            <a:endParaRPr lang="en-US" sz="1000" dirty="0"/>
           </a:p>
           <a:p>
             <a:pPr indent="0" marL="0">
@@ -8074,7 +8074,7 @@
               <a:buNone/>
             </a:pPr>
             <a:r>
-              <a:rPr lang="en-US" sz="1100" b="1" dirty="0">
+              <a:rPr lang="en-US" sz="1000" b="1" dirty="0">
                 <a:solidFill>
                   <a:srgbClr val="B5651D"/>
                 </a:solidFill>
@@ -8088,20 +8088,20 @@
               <a:buNone/>
             </a:pPr>
             <a:r>
-              <a:rPr lang="en-US" sz="1100" dirty="0">
+              <a:rPr lang="en-US" sz="1000" dirty="0">
                 <a:solidFill>
                   <a:srgbClr val="272425"/>
                 </a:solidFill>
               </a:rPr>
-              <a:t>Resumen al 26/2: VAN de 30.939 con los dos cambios, puesta en producción el 18/5, 2 días de reserva, presupuesto de cambio al 75 % tras la ampliación, 22,1 % del alcance en riesgo en el corte del 19/2 y 13 de 13 requisitos trazados.</a:t>
-            </a:r>
-            <a:endParaRPr lang="en-US" sz="1100" dirty="0"/>
+              <a:t>Resumen al 26/2: VAN de 30.939 con los dos cambios, puesta en producción el 20/5, 2 días de reserva, presupuesto de cambio al 75 % tras la ampliación, 22,1 % del alcance en riesgo en el corte del 19/2 y 13 de 13 requisitos trazados.</a:t>
+            </a:r>
+            <a:endParaRPr lang="en-US" sz="1000" dirty="0"/>
           </a:p>
         </p:txBody>
       </p:sp>
       <p:pic>
         <p:nvPicPr>
-          <p:cNvPr id="11" name="Image 0" descr="/home/claude/pm-method/docs/guias/img/g2-consumo-cambio.png">    </p:cNvPr>
+          <p:cNvPr id="11" name="Image 0" descr="/home/claude/pm-method/docs/guias/img/g2-impacto-c002.png">    </p:cNvPr>
           <p:cNvPicPr>
             <a:picLocks noChangeAspect="1"/>
           </p:cNvPicPr>
@@ -8153,7 +8153,7 @@
                   <a:srgbClr val="696969"/>
                 </a:solidFill>
               </a:rPr>
-              <a:t>Consumo del presupuesto de cambio en tres cortes</a:t>
+              <a:t>Límites que usaría C-002, según su análisis de impacto</a:t>
             </a:r>
             <a:endParaRPr lang="en-US" sz="1000" dirty="0"/>
           </a:p>
@@ -8324,7 +8324,7 @@
                   <a:srgbClr val="FFFFFF"/>
                 </a:solidFill>
               </a:rPr>
-              <a:t>E2E-3 · Interesados y OKR: el compromiso se mide en cada período</a:t>
+              <a:t>E2E-3 · Interesados y avance: compromiso y cifras verificados cada período</a:t>
             </a:r>
             <a:endParaRPr lang="en-US" sz="1900" dirty="0"/>
           </a:p>
@@ -8466,7 +8466,7 @@
               <a:buNone/>
             </a:pPr>
             <a:r>
-              <a:rPr lang="en-US" sz="1200" b="1" dirty="0">
+              <a:rPr lang="en-US" sz="1150" b="1" dirty="0">
                 <a:solidFill>
                   <a:srgbClr val="00629B"/>
                 </a:solidFill>
@@ -8480,14 +8480,14 @@
               <a:buNone/>
             </a:pPr>
             <a:r>
-              <a:rPr lang="en-US" sz="1200" dirty="0">
+              <a:rPr lang="en-US" sz="1150" dirty="0">
                 <a:solidFill>
                   <a:srgbClr val="272425"/>
                 </a:solidFill>
               </a:rPr>
-              <a:t>Maestro único de interesados: matriz, preferencias con cita y RACI</a:t>
-            </a:r>
-            <a:endParaRPr lang="en-US" sz="1200" dirty="0"/>
+              <a:t>Acuerdos del taller propuestos con cita y registrados solo al confirmarlos</a:t>
+            </a:r>
+            <a:endParaRPr lang="en-US" sz="1150" dirty="0"/>
           </a:p>
           <a:p>
             <a:pPr indent="0" marL="0">
@@ -8497,7 +8497,7 @@
               <a:buNone/>
             </a:pPr>
             <a:r>
-              <a:rPr lang="en-US" sz="1200" b="1" dirty="0">
+              <a:rPr lang="en-US" sz="1150" b="1" dirty="0">
                 <a:solidFill>
                   <a:srgbClr val="00629B"/>
                 </a:solidFill>
@@ -8511,14 +8511,14 @@
               <a:buNone/>
             </a:pPr>
             <a:r>
-              <a:rPr lang="en-US" sz="1200" dirty="0">
+              <a:rPr lang="en-US" sz="1150" dirty="0">
                 <a:solidFill>
                   <a:srgbClr val="272425"/>
                 </a:solidFill>
               </a:rPr>
-              <a:t>Highlight armado desde el dato y enviado por la capa de canales</a:t>
-            </a:r>
-            <a:endParaRPr lang="en-US" sz="1200" dirty="0"/>
+              <a:t>Radar de lo que hay que decidir hoy y highlight con las cifras verificadas contra el EVM</a:t>
+            </a:r>
+            <a:endParaRPr lang="en-US" sz="1150" dirty="0"/>
           </a:p>
           <a:p>
             <a:pPr indent="0" marL="0">
@@ -8528,7 +8528,7 @@
               <a:buNone/>
             </a:pPr>
             <a:r>
-              <a:rPr lang="en-US" sz="1200" b="1" dirty="0">
+              <a:rPr lang="en-US" sz="1150" b="1" dirty="0">
                 <a:solidFill>
                   <a:srgbClr val="00629B"/>
                 </a:solidFill>
@@ -8542,14 +8542,14 @@
               <a:buNone/>
             </a:pPr>
             <a:r>
-              <a:rPr lang="en-US" sz="1200" dirty="0">
+              <a:rPr lang="en-US" sz="1150" dirty="0">
                 <a:solidFill>
                   <a:srgbClr val="272425"/>
                 </a:solidFill>
               </a:rPr>
               <a:t>Cadencia de contacto y brecha de compromiso como control permanente</a:t>
             </a:r>
-            <a:endParaRPr lang="en-US" sz="1200" dirty="0"/>
+            <a:endParaRPr lang="en-US" sz="1150" dirty="0"/>
           </a:p>
         </p:txBody>
       </p:sp>
@@ -8733,7 +8733,7 @@
       </p:sp>
       <p:pic>
         <p:nvPicPr>
-          <p:cNvPr id="11" name="Image 0" descr="/home/claude/pm-method/docs/guias/img/g3-cadencia-stk12.png">    </p:cNvPr>
+          <p:cNvPr id="11" name="Image 0" descr="/home/claude/pm-method/docs/guias/img/g3-highlight-indicadores.png">    </p:cNvPr>
           <p:cNvPicPr>
             <a:picLocks noChangeAspect="1"/>
           </p:cNvPicPr>
@@ -8785,7 +8785,7 @@
                   <a:srgbClr val="696969"/>
                 </a:solidFill>
               </a:rPr>
-              <a:t>Cadencia de contacto al 5/2</a:t>
+              <a:t>Indicadores del highlight al 8/1</a:t>
             </a:r>
             <a:endParaRPr lang="en-US" sz="1000" dirty="0"/>
           </a:p>
@@ -8956,7 +8956,7 @@
                   <a:srgbClr val="FFFFFF"/>
                 </a:solidFill>
               </a:rPr>
-              <a:t>E2E-4 · Producto con BMAD: calidad a volumen y beneficios medidos después del cierre</a:t>
+              <a:t>E2E-4 · Producto con BMAD: calidad, cierre por id y beneficios medidos</a:t>
             </a:r>
             <a:endParaRPr lang="en-US" sz="1900" dirty="0"/>
           </a:p>
@@ -9148,7 +9148,7 @@
                   <a:srgbClr val="272425"/>
                 </a:solidFill>
               </a:rPr>
-              <a:t>Cada historia terminada con su revisión de calidad, incluido un rechazo</a:t>
+              <a:t>Retrospectiva con cita y ciclo de las lecciones: acción, verificación e índice de la organización</a:t>
             </a:r>
             <a:endParaRPr lang="en-US" sz="1150" dirty="0"/>
           </a:p>
@@ -9179,7 +9179,7 @@
                   <a:srgbClr val="272425"/>
                 </a:solidFill>
               </a:rPr>
-              <a:t>Beneficios medidos después del cierre contra trayectoria y tolerancia</a:t>
+              <a:t>Cierre verificado por id y expediente de auditoría con integridad comprobable</a:t>
             </a:r>
             <a:endParaRPr lang="en-US" sz="1150" dirty="0"/>
           </a:p>
@@ -9276,7 +9276,7 @@
               <a:buNone/>
             </a:pPr>
             <a:r>
-              <a:rPr lang="en-US" sz="1150" b="1" dirty="0">
+              <a:rPr lang="en-US" sz="1000" b="1" dirty="0">
                 <a:solidFill>
                   <a:srgbClr val="B5651D"/>
                 </a:solidFill>
@@ -9290,14 +9290,14 @@
               <a:buNone/>
             </a:pPr>
             <a:r>
-              <a:rPr lang="en-US" sz="1150" dirty="0">
+              <a:rPr lang="en-US" sz="1000" dirty="0">
                 <a:solidFill>
                   <a:srgbClr val="272425"/>
                 </a:solidFill>
               </a:rPr>
-              <a:t>Historias terminadas contra historias con revisión aprobada en cada corte: las brechas del 26/2 y del 7/5 se cerraron antes de la puerta siguiente (paso 8).</a:t>
-            </a:r>
-            <a:endParaRPr lang="en-US" sz="1150" dirty="0"/>
+              <a:t>Historias terminadas contra historias con revisión aprobada en cada corte, según el estado de productos que deriva estado.py productos: las brechas del 26/2 y del 7/5 se cerraron antes de la puerta siguiente (pasos 6 y 8).</a:t>
+            </a:r>
+            <a:endParaRPr lang="en-US" sz="1000" dirty="0"/>
           </a:p>
           <a:p>
             <a:pPr indent="0" marL="0">
@@ -9307,7 +9307,7 @@
               <a:buNone/>
             </a:pPr>
             <a:r>
-              <a:rPr lang="en-US" sz="1150" b="1" dirty="0">
+              <a:rPr lang="en-US" sz="1000" b="1" dirty="0">
                 <a:solidFill>
                   <a:srgbClr val="B5651D"/>
                 </a:solidFill>
@@ -9321,14 +9321,14 @@
               <a:buNone/>
             </a:pPr>
             <a:r>
-              <a:rPr lang="en-US" sz="1150" dirty="0">
+              <a:rPr lang="en-US" sz="1000" dirty="0">
                 <a:solidFill>
                   <a:srgbClr val="272425"/>
                 </a:solidFill>
               </a:rPr>
-              <a:t>La puerta de cierre en una página: 11 de 11 historias con revisión aprobada, CPI 0,977, 40 % del presupuesto de cambio usado y 0 condiciones abiertas (paso 9).</a:t>
-            </a:r>
-            <a:endParaRPr lang="en-US" sz="1150" dirty="0"/>
+              <a:t>De la retrospectiva del sprint 4 al índice de la organización: 3 lecciones con cita (1 de impacto alto), la acción de L-002 verificada en el sprint 5, L-003 cambia el plan de la etapa 3 y se verifica al cerrar el Release 2, y 3 lecciones en el índice (pasos 6c, 7, 8 y 9).</a:t>
+            </a:r>
+            <a:endParaRPr lang="en-US" sz="1000" dirty="0"/>
           </a:p>
           <a:p>
             <a:pPr indent="0" marL="0">
@@ -9338,7 +9338,7 @@
               <a:buNone/>
             </a:pPr>
             <a:r>
-              <a:rPr lang="en-US" sz="1150" b="1" dirty="0">
+              <a:rPr lang="en-US" sz="1000" b="1" dirty="0">
                 <a:solidFill>
                   <a:srgbClr val="B5651D"/>
                 </a:solidFill>
@@ -9352,20 +9352,20 @@
               <a:buNone/>
             </a:pPr>
             <a:r>
-              <a:rPr lang="en-US" sz="1150" dirty="0">
+              <a:rPr lang="en-US" sz="1000" dirty="0">
                 <a:solidFill>
                   <a:srgbClr val="272425"/>
                 </a:solidFill>
               </a:rPr>
-              <a:t>Al 31/12/2027, B-02 adopción llega al 83 % de la meta y queda fuera de la tolerancia de −10 %; B-01 y B-03, dentro (paso 11).</a:t>
-            </a:r>
-            <a:endParaRPr lang="en-US" sz="1150" dirty="0"/>
+              <a:t>El expediente para la auditoría externa: 41 eventos en la cronología y 43 archivos con su huella; una sola palabra cambiada en la copia y la verificación la delata (paso 9b).</a:t>
+            </a:r>
+            <a:endParaRPr lang="en-US" sz="1000" dirty="0"/>
           </a:p>
         </p:txBody>
       </p:sp>
       <p:pic>
         <p:nvPicPr>
-          <p:cNvPr id="11" name="Image 0" descr="/home/claude/pm-method/docs/guias/img/g4-calidad-entregas.png">    </p:cNvPr>
+          <p:cNvPr id="11" name="Image 0" descr="/home/claude/pm-method/docs/guias/img/g4-cierre.png">    </p:cNvPr>
           <p:cNvPicPr>
             <a:picLocks noChangeAspect="1"/>
           </p:cNvPicPr>
@@ -9417,7 +9417,7 @@
                   <a:srgbClr val="696969"/>
                 </a:solidFill>
               </a:rPr>
-              <a:t>Calidad por entrega</a:t>
+              <a:t>Tablero de cierre</a:t>
             </a:r>
             <a:endParaRPr lang="en-US" sz="1000" dirty="0"/>
           </a:p>
@@ -9480,7 +9480,7 @@
                   <a:srgbClr val="002855"/>
                 </a:solidFill>
               </a:rPr>
-              <a:t>12 pasos · 2 clases de webinar · guía docs/guias/E2E-4-producto-bmad.md</a:t>
+              <a:t>15 pasos · 2 clases de webinar · guía docs/guias/E2E-4-producto-bmad.md</a:t>
             </a:r>
             <a:endParaRPr lang="en-US" sz="1050" dirty="0"/>
           </a:p>
@@ -9749,7 +9749,7 @@
                   <a:srgbClr val="272425"/>
                 </a:solidFill>
               </a:rPr>
-              <a:t>Mapa de supuestos y experimentos baratos antes de comprometer dinero</a:t>
+              <a:t>Lecciones de otros proyectos y mapa de supuestos antes de comprometer dinero</a:t>
             </a:r>
             <a:endParaRPr lang="en-US" sz="1150" dirty="0"/>
           </a:p>
@@ -9811,7 +9811,7 @@
                   <a:srgbClr val="272425"/>
                 </a:solidFill>
               </a:rPr>
-              <a:t>Mapa de Wardley y recorrido del paciente para decidir qué construir</a:t>
+              <a:t>Personas de usuario ligadas a cada requisito Must, y mapas para decidir qué construir</a:t>
             </a:r>
             <a:endParaRPr lang="en-US" sz="1150" dirty="0"/>
           </a:p>
@@ -9908,7 +9908,7 @@
               <a:buNone/>
             </a:pPr>
             <a:r>
-              <a:rPr lang="en-US" sz="1150" b="1" dirty="0">
+              <a:rPr lang="en-US" sz="1100" b="1" dirty="0">
                 <a:solidFill>
                   <a:srgbClr val="B5651D"/>
                 </a:solidFill>
@@ -9922,14 +9922,14 @@
               <a:buNone/>
             </a:pPr>
             <a:r>
-              <a:rPr lang="en-US" sz="1150" dirty="0">
+              <a:rPr lang="en-US" sz="1100" dirty="0">
                 <a:solidFill>
                   <a:srgbClr val="272425"/>
                 </a:solidFill>
               </a:rPr>
               <a:t>Tres supuestos críticos sin evidencia (S-001, S-002, S-003) sostienen los dos beneficios y la factibilidad: ahí se invierte primero en aprender (paso 2).</a:t>
             </a:r>
-            <a:endParaRPr lang="en-US" sz="1150" dirty="0"/>
+            <a:endParaRPr lang="en-US" sz="1100" dirty="0"/>
           </a:p>
           <a:p>
             <a:pPr indent="0" marL="0">
@@ -9939,7 +9939,7 @@
               <a:buNone/>
             </a:pPr>
             <a:r>
-              <a:rPr lang="en-US" sz="1150" b="1" dirty="0">
+              <a:rPr lang="en-US" sz="1100" b="1" dirty="0">
                 <a:solidFill>
                   <a:srgbClr val="B5651D"/>
                 </a:solidFill>
@@ -9953,14 +9953,14 @@
               <a:buNone/>
             </a:pPr>
             <a:r>
-              <a:rPr lang="en-US" sz="1150" dirty="0">
+              <a:rPr lang="en-US" sz="1100" dirty="0">
                 <a:solidFill>
                   <a:srgbClr val="272425"/>
                 </a:solidFill>
               </a:rPr>
               <a:t>El piloto bajó el VAN de las dos opciones; la opción 2 sigue siendo la mejor, con una TIR de 54,3 % y un repago de 1,78 años (paso 4).</a:t>
             </a:r>
-            <a:endParaRPr lang="en-US" sz="1150" dirty="0"/>
+            <a:endParaRPr lang="en-US" sz="1100" dirty="0"/>
           </a:p>
           <a:p>
             <a:pPr indent="0" marL="0">
@@ -9970,7 +9970,7 @@
               <a:buNone/>
             </a:pPr>
             <a:r>
-              <a:rPr lang="en-US" sz="1150" b="1" dirty="0">
+              <a:rPr lang="en-US" sz="1100" b="1" dirty="0">
                 <a:solidFill>
                   <a:srgbClr val="B5651D"/>
                 </a:solidFill>
@@ -9984,14 +9984,14 @@
               <a:buNone/>
             </a:pPr>
             <a:r>
-              <a:rPr lang="en-US" sz="1150" dirty="0">
+              <a:rPr lang="en-US" sz="1100" dirty="0">
                 <a:solidFill>
                   <a:srgbClr val="272425"/>
                 </a:solidFill>
               </a:rPr>
-              <a:t>La junta autoriza USD 179.340 (BAC 170.800 + reserva de gestión 8.540) y fija aparte un presupuesto de cambio de 10.000 con tope de 3.000 por cambio (paso 9).</a:t>
-            </a:r>
-            <a:endParaRPr lang="en-US" sz="1150" dirty="0"/>
+              <a:t>Los 4 Must tienen persona y REQ-003 sirve al paciente, a la recepcionista y al paciente mayor de 65; el aviso STK-13 de REQ-006 se resolvió marcando al paciente como beneficiario (paso 10b).</a:t>
+            </a:r>
+            <a:endParaRPr lang="en-US" sz="1100" dirty="0"/>
           </a:p>
         </p:txBody>
       </p:sp>
@@ -10112,7 +10112,7 @@
                   <a:srgbClr val="002855"/>
                 </a:solidFill>
               </a:rPr>
-              <a:t>18 pasos · 2 clases de webinar · guía docs/guias/E2E-5-idea-a-proyecto.md</a:t>
+              <a:t>20 pasos · 2 clases de webinar · guía docs/guias/E2E-5-idea-a-proyecto.md</a:t>
             </a:r>
             <a:endParaRPr lang="en-US" sz="1050" dirty="0"/>
           </a:p>
@@ -10283,7 +10283,7 @@
                   <a:srgbClr val="FFFFFF"/>
                 </a:solidFill>
               </a:rPr>
-              <a:t>223</a:t>
+              <a:t>353</a:t>
             </a:r>
             <a:endParaRPr lang="en-US" sz="2800" dirty="0"/>
           </a:p>
@@ -10355,7 +10355,7 @@
                   <a:srgbClr val="FFFFFF"/>
                 </a:solidFill>
               </a:rPr>
-              <a:t>0 FALLO · 21 casos</a:t>
+              <a:t>0 FALLO · 33 casos</a:t>
             </a:r>
             <a:endParaRPr lang="en-US" sz="1000" dirty="0"/>
           </a:p>
@@ -10553,7 +10553,7 @@
                   <a:srgbClr val="FFFFFF"/>
                 </a:solidFill>
               </a:rPr>
-              <a:t>127</a:t>
+              <a:t>128</a:t>
             </a:r>
             <a:endParaRPr lang="en-US" sz="2800" dirty="0"/>
           </a:p>
@@ -10688,7 +10688,7 @@
                   <a:srgbClr val="FFFFFF"/>
                 </a:solidFill>
               </a:rPr>
-              <a:t>102</a:t>
+              <a:t>130</a:t>
             </a:r>
             <a:endParaRPr lang="en-US" sz="2800" dirty="0"/>
           </a:p>
@@ -10859,7 +10859,7 @@
                   <a:srgbClr val="B5651D"/>
                 </a:solidFill>
               </a:rPr>
-              <a:t>14/14  </a:t>
+              <a:t>2/2  </a:t>
             </a:r>
             <a:pPr indent="0" marL="0">
               <a:buNone/>
@@ -10870,7 +10870,7 @@
                   <a:srgbClr val="272425"/>
                 </a:solidFill>
               </a:rPr>
-              <a:t>enrutamiento  </a:t>
+              <a:t>enrutamiento, ids 103–104  </a:t>
             </a:r>
             <a:pPr indent="0" marL="0">
               <a:spcAft>
@@ -10884,7 +10884,7 @@
                   <a:srgbClr val="696969"/>
                 </a:solidFill>
               </a:rPr>
-              <a:t>20/10</a:t>
+              <a:t>21/10</a:t>
             </a:r>
             <a:endParaRPr lang="en-US" sz="1200" dirty="0"/>
           </a:p>
@@ -10898,7 +10898,7 @@
                   <a:srgbClr val="B5651D"/>
                 </a:solidFill>
               </a:rPr>
-              <a:t>8/8  </a:t>
+              <a:t>3/3  </a:t>
             </a:r>
             <a:pPr indent="0" marL="0">
               <a:buNone/>
@@ -10909,7 +10909,7 @@
                   <a:srgbClr val="272425"/>
                 </a:solidFill>
               </a:rPr>
-              <a:t>enrutamiento, ids 95–102  </a:t>
+              <a:t>enrutamiento, ids 105–107  </a:t>
             </a:r>
             <a:pPr indent="0" marL="0">
               <a:spcAft>
@@ -10923,7 +10923,7 @@
                   <a:srgbClr val="696969"/>
                 </a:solidFill>
               </a:rPr>
-              <a:t>20/10</a:t>
+              <a:t>21/10</a:t>
             </a:r>
             <a:endParaRPr lang="en-US" sz="1200" dirty="0"/>
           </a:p>
@@ -10937,7 +10937,7 @@
                   <a:srgbClr val="B5651D"/>
                 </a:solidFill>
               </a:rPr>
-              <a:t>7/7  </a:t>
+              <a:t>12/12  </a:t>
             </a:r>
             <a:pPr indent="0" marL="0">
               <a:buNone/>
@@ -10948,7 +10948,7 @@
                   <a:srgbClr val="272425"/>
                 </a:solidFill>
               </a:rPr>
-              <a:t>controles, tras el control de autoridad y p…  </a:t>
+              <a:t>enrutamiento, ids 108–114  </a:t>
             </a:r>
             <a:pPr indent="0" marL="0">
               <a:spcAft>
@@ -10962,7 +10962,7 @@
                   <a:srgbClr val="696969"/>
                 </a:solidFill>
               </a:rPr>
-              <a:t>20/10</a:t>
+              <a:t>21/10</a:t>
             </a:r>
             <a:endParaRPr lang="en-US" sz="1200" dirty="0"/>
           </a:p>
@@ -10976,7 +10976,7 @@
                   <a:srgbClr val="B5651D"/>
                 </a:solidFill>
               </a:rPr>
-              <a:t>12/12  </a:t>
+              <a:t>6/6 · 8/8  </a:t>
             </a:r>
             <a:pPr indent="0" marL="0">
               <a:buNone/>
@@ -10987,7 +10987,7 @@
                   <a:srgbClr val="272425"/>
                 </a:solidFill>
               </a:rPr>
-              <a:t>integracion con las 29 skills de BMAD 6.12.…  </a:t>
+              <a:t>enrutamiento, ids 115–120  </a:t>
             </a:r>
             <a:pPr indent="0" marL="0">
               <a:spcAft>
@@ -11001,7 +11001,163 @@
                   <a:srgbClr val="696969"/>
                 </a:solidFill>
               </a:rPr>
-              <a:t>20/10</a:t>
+              <a:t>21/10</a:t>
+            </a:r>
+            <a:endParaRPr lang="en-US" sz="1200" dirty="0"/>
+          </a:p>
+          <a:p>
+            <a:pPr indent="0" marL="0">
+              <a:buNone/>
+            </a:pPr>
+            <a:r>
+              <a:rPr lang="en-US" sz="1100" b="1" dirty="0">
+                <a:solidFill>
+                  <a:srgbClr val="B5651D"/>
+                </a:solidFill>
+              </a:rPr>
+              <a:t>4/4 · 10/10  </a:t>
+            </a:r>
+            <a:pPr indent="0" marL="0">
+              <a:buNone/>
+            </a:pPr>
+            <a:r>
+              <a:rPr lang="en-US" sz="1100" dirty="0">
+                <a:solidFill>
+                  <a:srgbClr val="272425"/>
+                </a:solidFill>
+              </a:rPr>
+              <a:t>enrutamiento, ids 121–124  </a:t>
+            </a:r>
+            <a:pPr indent="0" marL="0">
+              <a:spcAft>
+                <a:spcPts val="400"/>
+              </a:spcAft>
+              <a:buNone/>
+            </a:pPr>
+            <a:r>
+              <a:rPr lang="en-US" sz="1000" dirty="0">
+                <a:solidFill>
+                  <a:srgbClr val="696969"/>
+                </a:solidFill>
+              </a:rPr>
+              <a:t>21/10</a:t>
+            </a:r>
+            <a:endParaRPr lang="en-US" sz="1200" dirty="0"/>
+          </a:p>
+          <a:p>
+            <a:pPr indent="0" marL="0">
+              <a:buNone/>
+            </a:pPr>
+            <a:r>
+              <a:rPr lang="en-US" sz="1100" b="1" dirty="0">
+                <a:solidFill>
+                  <a:srgbClr val="B5651D"/>
+                </a:solidFill>
+              </a:rPr>
+              <a:t>2/2  </a:t>
+            </a:r>
+            <a:pPr indent="0" marL="0">
+              <a:buNone/>
+            </a:pPr>
+            <a:r>
+              <a:rPr lang="en-US" sz="1100" dirty="0">
+                <a:solidFill>
+                  <a:srgbClr val="272425"/>
+                </a:solidFill>
+              </a:rPr>
+              <a:t>enrutamiento, ids 125–126  </a:t>
+            </a:r>
+            <a:pPr indent="0" marL="0">
+              <a:spcAft>
+                <a:spcPts val="400"/>
+              </a:spcAft>
+              <a:buNone/>
+            </a:pPr>
+            <a:r>
+              <a:rPr lang="en-US" sz="1000" dirty="0">
+                <a:solidFill>
+                  <a:srgbClr val="696969"/>
+                </a:solidFill>
+              </a:rPr>
+              <a:t>22/10</a:t>
+            </a:r>
+            <a:endParaRPr lang="en-US" sz="1200" dirty="0"/>
+          </a:p>
+          <a:p>
+            <a:pPr indent="0" marL="0">
+              <a:buNone/>
+            </a:pPr>
+            <a:r>
+              <a:rPr lang="en-US" sz="1100" b="1" dirty="0">
+                <a:solidFill>
+                  <a:srgbClr val="B5651D"/>
+                </a:solidFill>
+              </a:rPr>
+              <a:t>4/4  </a:t>
+            </a:r>
+            <a:pPr indent="0" marL="0">
+              <a:buNone/>
+            </a:pPr>
+            <a:r>
+              <a:rPr lang="en-US" sz="1100" dirty="0">
+                <a:solidFill>
+                  <a:srgbClr val="272425"/>
+                </a:solidFill>
+              </a:rPr>
+              <a:t>enrutamiento, ids 127–128  </a:t>
+            </a:r>
+            <a:pPr indent="0" marL="0">
+              <a:spcAft>
+                <a:spcPts val="400"/>
+              </a:spcAft>
+              <a:buNone/>
+            </a:pPr>
+            <a:r>
+              <a:rPr lang="en-US" sz="1000" dirty="0">
+                <a:solidFill>
+                  <a:srgbClr val="696969"/>
+                </a:solidFill>
+              </a:rPr>
+              <a:t>22/10</a:t>
+            </a:r>
+            <a:endParaRPr lang="en-US" sz="1200" dirty="0"/>
+          </a:p>
+          <a:p>
+            <a:pPr indent="0" marL="0">
+              <a:buNone/>
+            </a:pPr>
+            <a:r>
+              <a:rPr lang="en-US" sz="1100" b="1" dirty="0">
+                <a:solidFill>
+                  <a:srgbClr val="B5651D"/>
+                </a:solidFill>
+              </a:rPr>
+              <a:t>2/2  </a:t>
+            </a:r>
+            <a:pPr indent="0" marL="0">
+              <a:buNone/>
+            </a:pPr>
+            <a:r>
+              <a:rPr lang="en-US" sz="1100" dirty="0">
+                <a:solidFill>
+                  <a:srgbClr val="272425"/>
+                </a:solidFill>
+              </a:rPr>
+              <a:t>enrutamiento, ids 129–130  </a:t>
+            </a:r>
+            <a:pPr indent="0" marL="0">
+              <a:spcAft>
+                <a:spcPts val="400"/>
+              </a:spcAft>
+              <a:buNone/>
+            </a:pPr>
+            <a:r>
+              <a:rPr lang="en-US" sz="1000" dirty="0">
+                <a:solidFill>
+                  <a:srgbClr val="696969"/>
+                </a:solidFill>
+              </a:rPr>
+              <a:t>22/10</a:t>
             </a:r>
             <a:endParaRPr lang="en-US" sz="1200" dirty="0"/>
           </a:p>
@@ -16517,7 +16673,7 @@
                   <a:srgbClr val="272425"/>
                 </a:solidFill>
               </a:rPr>
-              <a:t>Los cambios se aprueban uno a uno y nadie suma lo comprometido</a:t>
+              <a:t>La respuesta a un riesgo se elige por intuición y la contingencia se improvisa</a:t>
             </a:r>
             <a:endParaRPr lang="en-US" sz="1200" dirty="0"/>
           </a:p>
@@ -16616,7 +16772,7 @@
                   <a:srgbClr val="002855"/>
                 </a:solidFill>
               </a:rPr>
-              <a:t>Cada cambio se carga contra el presupuesto de la junta; excedido, bloquea la puerta</a:t>
+              <a:t>Opciones comparadas por valor neto; decide el propietario y el plan de contingencia queda listo</a:t>
             </a:r>
             <a:endParaRPr lang="en-US" sz="1200" dirty="0"/>
           </a:p>
@@ -16682,7 +16838,7 @@
                 <a:ea typeface="Courier New" pitchFamily="34" charset="-122"/>
                 <a:cs typeface="Courier New" pitchFamily="34" charset="-120"/>
               </a:rPr>
-              <a:t>CAM-03 · CAM-04</a:t>
+              <a:t>REG-10</a:t>
             </a:r>
             <a:endParaRPr lang="en-US" sz="1000" dirty="0"/>
           </a:p>
@@ -16745,7 +16901,7 @@
                   <a:srgbClr val="272425"/>
                 </a:solidFill>
               </a:rPr>
-              <a:t>«Aprobado con condiciones» queda en el acta y se olvida</a:t>
+              <a:t>Los cambios se aprueban uno a uno y nadie suma lo comprometido</a:t>
             </a:r>
             <a:endParaRPr lang="en-US" sz="1200" dirty="0"/>
           </a:p>
@@ -16844,7 +17000,7 @@
                   <a:srgbClr val="002855"/>
                 </a:solidFill>
               </a:rPr>
-              <a:t>La condición se sigue hasta que alguien con rol la cierra; abierta, bloquea el cierre</a:t>
+              <a:t>Cada cambio se mide antes de decidirlo y se carga contra el presupuesto de la junta</a:t>
             </a:r>
             <a:endParaRPr lang="en-US" sz="1200" dirty="0"/>
           </a:p>
@@ -16910,7 +17066,7 @@
                 <a:ea typeface="Courier New" pitchFamily="34" charset="-122"/>
                 <a:cs typeface="Courier New" pitchFamily="34" charset="-120"/>
               </a:rPr>
-              <a:t>EST-12 · G-01</a:t>
+              <a:t>CAM-03 · CAM-04</a:t>
             </a:r>
             <a:endParaRPr lang="en-US" sz="1000" dirty="0"/>
           </a:p>
@@ -16973,7 +17129,7 @@
                   <a:srgbClr val="272425"/>
                 </a:solidFill>
               </a:rPr>
-              <a:t>La calidad se revisa al final, si se revisa</a:t>
+              <a:t>«Aprobado con condiciones» queda en el acta y se olvida</a:t>
             </a:r>
             <a:endParaRPr lang="en-US" sz="1200" dirty="0"/>
           </a:p>
@@ -17072,7 +17228,7 @@
                   <a:srgbClr val="002855"/>
                 </a:solidFill>
               </a:rPr>
-              <a:t>Cada historia terminada necesita su revisión aprobada, en cada entrega</a:t>
+              <a:t>La condición se sigue hasta que alguien con rol la cierra; abierta, bloquea el cierre</a:t>
             </a:r>
             <a:endParaRPr lang="en-US" sz="1200" dirty="0"/>
           </a:p>
@@ -17138,7 +17294,7 @@
                 <a:ea typeface="Courier New" pitchFamily="34" charset="-122"/>
                 <a:cs typeface="Courier New" pitchFamily="34" charset="-120"/>
               </a:rPr>
-              <a:t>QUA-01 · QUA-02</a:t>
+              <a:t>EST-12 · G-01</a:t>
             </a:r>
             <a:endParaRPr lang="en-US" sz="1000" dirty="0"/>
           </a:p>
@@ -17201,7 +17357,7 @@
                   <a:srgbClr val="272425"/>
                 </a:solidFill>
               </a:rPr>
-              <a:t>El pronóstico de valor ganado no se vuelve a mirar</a:t>
+              <a:t>La calidad se revisa al final y el cierre se firma de memoria</a:t>
             </a:r>
             <a:endParaRPr lang="en-US" sz="1200" dirty="0"/>
           </a:p>
@@ -17300,7 +17456,7 @@
                   <a:srgbClr val="002855"/>
                 </a:solidFill>
               </a:rPr>
-              <a:t>Un pronóstico fuera de tolerancia sin excepción abierta genera aviso</a:t>
+              <a:t>Cada historia terminada necesita su revisión, y el cierre lista por id lo que falta aceptar</a:t>
             </a:r>
             <a:endParaRPr lang="en-US" sz="1200" dirty="0"/>
           </a:p>
@@ -17366,7 +17522,7 @@
                 <a:ea typeface="Courier New" pitchFamily="34" charset="-122"/>
                 <a:cs typeface="Courier New" pitchFamily="34" charset="-120"/>
               </a:rPr>
-              <a:t>TOL-01</a:t>
+              <a:t>QUA-01 · C-07</a:t>
             </a:r>
             <a:endParaRPr lang="en-US" sz="1000" dirty="0"/>
           </a:p>
@@ -17429,7 +17585,7 @@
                   <a:srgbClr val="272425"/>
                 </a:solidFill>
               </a:rPr>
-              <a:t>El plan de comunicaciones promete una frecuencia que nadie verifica</a:t>
+              <a:t>Las lecciones se archivan en un informe que nadie vuelve a leer</a:t>
             </a:r>
             <a:endParaRPr lang="en-US" sz="1200" dirty="0"/>
           </a:p>
@@ -17528,7 +17684,7 @@
                   <a:srgbClr val="002855"/>
                 </a:solidFill>
               </a:rPr>
-              <a:t>La cadencia de contacto de cada interesado clave queda vigilada</a:t>
+              <a:t>Cada lección de impacto alto se acciona, se verifica que funcionó y alimenta a otros proyectos</a:t>
             </a:r>
             <a:endParaRPr lang="en-US" sz="1200" dirty="0"/>
           </a:p>
@@ -17594,7 +17750,7 @@
                 <a:ea typeface="Courier New" pitchFamily="34" charset="-122"/>
                 <a:cs typeface="Courier New" pitchFamily="34" charset="-120"/>
               </a:rPr>
-              <a:t>STK-12</a:t>
+              <a:t>REG-11 · REG-12</a:t>
             </a:r>
             <a:endParaRPr lang="en-US" sz="1000" dirty="0"/>
           </a:p>
@@ -19670,7 +19826,7 @@
                   <a:srgbClr val="002855"/>
                 </a:solidFill>
               </a:rPr>
-              <a:t>13  </a:t>
+              <a:t>14  </a:t>
             </a:r>
             <a:pPr indent="0" marL="0">
               <a:buNone/>
@@ -19717,7 +19873,7 @@
                   <a:srgbClr val="696969"/>
                 </a:solidFill>
               </a:rPr>
-              <a:t>9 base y 4 que se crean al primer uso</a:t>
+              <a:t>9 base y 5 que se crean al primer uso</a:t>
             </a:r>
             <a:endParaRPr lang="en-US" sz="1200" dirty="0"/>
           </a:p>
@@ -19890,7 +20046,7 @@
                   <a:srgbClr val="002855"/>
                 </a:solidFill>
               </a:rPr>
-              <a:t>97  </a:t>
+              <a:t>105  </a:t>
             </a:r>
             <a:pPr indent="0" marL="0">
               <a:buNone/>
@@ -19937,7 +20093,7 @@
                   <a:srgbClr val="696969"/>
                 </a:solidFill>
               </a:rPr>
-              <a:t>85 de sanidad y 12 de puerta</a:t>
+              <a:t>93 de sanidad y 12 de puerta</a:t>
             </a:r>
             <a:endParaRPr lang="en-US" sz="1200" dirty="0"/>
           </a:p>
@@ -24719,7 +24875,7 @@
                   <a:srgbClr val="FFFFFF"/>
                 </a:solidFill>
               </a:rPr>
-              <a:t>97 controles automáticos vigilan lo que nadie revisa a mano</a:t>
+              <a:t>105 controles automáticos vigilan lo que nadie revisa a mano</a:t>
             </a:r>
             <a:endParaRPr lang="en-US" sz="1900" dirty="0"/>
           </a:p>
@@ -25041,7 +25197,7 @@
                   <a:srgbClr val="B5651D"/>
                 </a:solidFill>
               </a:rPr>
-              <a:t>E2E-2</a:t>
+              <a:t>E2E-1</a:t>
             </a:r>
             <a:endParaRPr lang="en-US" sz="1100" dirty="0"/>
           </a:p>
@@ -25072,12 +25228,12 @@
               <a:buNone/>
             </a:pPr>
             <a:r>
-              <a:rPr lang="en-US" sz="1150" dirty="0">
+              <a:rPr lang="en-US" sz="950" dirty="0">
                 <a:solidFill>
                   <a:srgbClr val="272425"/>
                 </a:solidFill>
               </a:rPr>
-              <a:t>El presupuesto de cambio queda en 75 % tras C-001; con C-002 llegaría al 200 %, por eso C-002 espera a la junta, que amplía el presupuesto y lo aprueba: vuelve a 75 % (paso 10).</a:t>
+              <a:t>La reserva pasa del 18 % al 94 % en cinco corridas de la sanidad; al activar el plan de contingencia de R-003 cruza el 80 % y CAM-03 deja de ser informativo y avisa. La provisión para lo no identificado no está en esas barras: vive en la reserva de gestión, que solo libera la junta.</a:t>
             </a:r>
             <a:endParaRPr lang="en-US" sz="1200" dirty="0"/>
           </a:p>
@@ -25170,7 +25326,7 @@
                 <a:ea typeface="Courier New" pitchFamily="34" charset="-122"/>
                 <a:cs typeface="Courier New" pitchFamily="34" charset="-120"/>
               </a:rPr>
-              <a:t>CAM-03</a:t>
+              <a:t>STK-12</a:t>
             </a:r>
             <a:endParaRPr lang="en-US" sz="1000" dirty="0"/>
           </a:p>
@@ -25206,7 +25362,7 @@
                   <a:srgbClr val="B5651D"/>
                 </a:solidFill>
               </a:rPr>
-              <a:t>E2E-1</a:t>
+              <a:t>E2E-3</a:t>
             </a:r>
             <a:endParaRPr lang="en-US" sz="1100" dirty="0"/>
           </a:p>
@@ -25242,7 +25398,7 @@
                   <a:srgbClr val="272425"/>
                 </a:solidFill>
               </a:rPr>
-              <a:t>La reserva pasa del 21 % al 81 % en cinco corridas de la sanidad; al cruzar el 80 %, CAM-03 deja de ser informativo y avisa.</a:t>
+              <a:t>STK-12 al 5/2: TI, Martín y Lucía superan el máximo de días sin contacto. Laura, Sofía y el sindicato están en el límite.</a:t>
             </a:r>
             <a:endParaRPr lang="en-US" sz="1200" dirty="0"/>
           </a:p>
@@ -25335,7 +25491,7 @@
                 <a:ea typeface="Courier New" pitchFamily="34" charset="-122"/>
                 <a:cs typeface="Courier New" pitchFamily="34" charset="-120"/>
               </a:rPr>
-              <a:t>STK-12</a:t>
+              <a:t>QUA-01</a:t>
             </a:r>
             <a:endParaRPr lang="en-US" sz="1000" dirty="0"/>
           </a:p>
@@ -25371,7 +25527,7 @@
                   <a:srgbClr val="B5651D"/>
                 </a:solidFill>
               </a:rPr>
-              <a:t>E2E-3</a:t>
+              <a:t>E2E-4</a:t>
             </a:r>
             <a:endParaRPr lang="en-US" sz="1100" dirty="0"/>
           </a:p>
@@ -25402,12 +25558,12 @@
               <a:buNone/>
             </a:pPr>
             <a:r>
-              <a:rPr lang="en-US" sz="1150" dirty="0">
+              <a:rPr lang="en-US" sz="950" dirty="0">
                 <a:solidFill>
                   <a:srgbClr val="272425"/>
                 </a:solidFill>
               </a:rPr>
-              <a:t>STK-12 al 5/2: TI, Martín y Lucía superan el máximo de días sin contacto. Laura, Sofía y el sindicato están en el límite.</a:t>
+              <a:t>Historias terminadas contra historias con revisión aprobada en cada corte, según el estado de productos que deriva estado.py productos: las brechas del 26/2 y del 7/5 se cerraron antes de la puerta siguiente (pasos 6 y 8).</a:t>
             </a:r>
             <a:endParaRPr lang="en-US" sz="1200" dirty="0"/>
           </a:p>
@@ -25500,7 +25656,7 @@
                 <a:ea typeface="Courier New" pitchFamily="34" charset="-122"/>
                 <a:cs typeface="Courier New" pitchFamily="34" charset="-120"/>
               </a:rPr>
-              <a:t>QUA-01</a:t>
+              <a:t>REG-11</a:t>
             </a:r>
             <a:endParaRPr lang="en-US" sz="1000" dirty="0"/>
           </a:p>
@@ -25567,12 +25723,12 @@
               <a:buNone/>
             </a:pPr>
             <a:r>
-              <a:rPr lang="en-US" sz="1150" dirty="0">
+              <a:rPr lang="en-US" sz="950" dirty="0">
                 <a:solidFill>
                   <a:srgbClr val="272425"/>
                 </a:solidFill>
               </a:rPr>
-              <a:t>Historias terminadas contra historias con revisión aprobada en cada corte: las brechas del 26/2 y del 7/5 se cerraron antes de la puerta siguiente (paso 8).</a:t>
+              <a:t>De la retrospectiva del sprint 4 al índice de la organización: 3 lecciones con cita (1 de impacto alto), la acción de L-002 verificada en el sprint 5, L-003 cambia el plan de la etapa 3 y se verifica al cerrar el Release 2, y 3 lecciones en el índice (pasos 6c, 7, 8 y 9).</a:t>
             </a:r>
             <a:endParaRPr lang="en-US" sz="1200" dirty="0"/>
           </a:p>
@@ -26149,12 +26305,12 @@
               <a:buNone/>
             </a:pPr>
             <a:r>
-              <a:rPr lang="en-US" sz="1100" dirty="0">
+              <a:rPr lang="en-US" sz="1050" dirty="0">
                 <a:solidFill>
                   <a:srgbClr val="272425"/>
                 </a:solidFill>
               </a:rPr>
-              <a:t>Actas con acciones, riesgos, decisiones y preferencias declaradas, confirmadas por una persona.</a:t>
+              <a:t>Acuerdos con cita: decisiones, compromisos, supuestos, riesgos y lecciones propuestos desde la transcripción y registrados solo si una persona los confirma.</a:t>
             </a:r>
             <a:endParaRPr lang="en-US" sz="1200" dirty="0"/>
           </a:p>

</xml_diff>